<commit_message>
Update public deck to final midterm version (speaker notes removed)
Co-Authored-By: Claude Opus 5.5 <noreply@anthropic.com>
</commit_message>
<xml_diff>
--- a/docs/presentation/biz-risk-predictor_mid_public.pptx
+++ b/docs/presentation/biz-risk-predictor_mid_public.pptx
@@ -20,9 +20,14 @@
   <p:notesSz cx="5143500" cy="9144000"/>
   <p:embeddedFontLst>
     <p:embeddedFont>
-      <p:font typeface="Pretendard" panose="02000503000000020004" pitchFamily="2" charset="-127"/>
+      <p:font typeface="맑은 고딕" panose="020B0503020000020004" pitchFamily="34" charset="-127"/>
       <p:regular r:id="rId10"/>
       <p:bold r:id="rId11"/>
+    </p:embeddedFont>
+    <p:embeddedFont>
+      <p:font typeface="Pretendard" panose="02000503000000020004" pitchFamily="2" charset="-127"/>
+      <p:regular r:id="rId12"/>
+      <p:bold r:id="rId13"/>
     </p:embeddedFont>
   </p:embeddedFontLst>
   <p:defaultTextStyle>
@@ -295,9 +300,126 @@
           <a:lstStyle/>
           <a:p>
             <a:r>
-              <a:rPr lang="en-US" dirty="0"/>
-              <a:t/>
-            </a:r>
+              <a:rPr lang="ko-KR" altLang="en-US" sz="1200" b="0" i="0" kern="1200" dirty="0">
+                <a:solidFill>
+                  <a:schemeClr val="tx1"/>
+                </a:solidFill>
+                <a:effectLst/>
+                <a:latin typeface="+mn-lt"/>
+                <a:ea typeface="+mn-ea"/>
+                <a:cs typeface="+mn-cs"/>
+              </a:rPr>
+              <a:t/>
+            </a:r>
+            <a:r>
+              <a:rPr lang="en-US" altLang="ko-KR" sz="1200" b="0" i="0" kern="1200" dirty="0">
+                <a:solidFill>
+                  <a:schemeClr val="tx1"/>
+                </a:solidFill>
+                <a:effectLst/>
+                <a:latin typeface="+mn-lt"/>
+                <a:ea typeface="+mn-ea"/>
+                <a:cs typeface="+mn-cs"/>
+              </a:rPr>
+              <a:t/>
+            </a:r>
+            <a:r>
+              <a:rPr lang="ko-KR" altLang="en-US" sz="1200" b="0" i="0" kern="1200" dirty="0">
+                <a:solidFill>
+                  <a:schemeClr val="tx1"/>
+                </a:solidFill>
+                <a:effectLst/>
+                <a:latin typeface="+mn-lt"/>
+                <a:ea typeface="+mn-ea"/>
+                <a:cs typeface="+mn-cs"/>
+              </a:rPr>
+              <a:t/>
+            </a:r>
+            <a:r>
+              <a:rPr lang="en-US" altLang="ko-KR" sz="1200" b="0" i="0" kern="1200" dirty="0">
+                <a:solidFill>
+                  <a:schemeClr val="tx1"/>
+                </a:solidFill>
+                <a:effectLst/>
+                <a:latin typeface="+mn-lt"/>
+                <a:ea typeface="+mn-ea"/>
+                <a:cs typeface="+mn-cs"/>
+              </a:rPr>
+              <a:t/>
+            </a:r>
+            <a:r>
+              <a:rPr lang="ko-KR" altLang="en-US" sz="1200" b="0" i="0" kern="1200" dirty="0">
+                <a:solidFill>
+                  <a:schemeClr val="tx1"/>
+                </a:solidFill>
+                <a:effectLst/>
+                <a:latin typeface="+mn-lt"/>
+                <a:ea typeface="+mn-ea"/>
+                <a:cs typeface="+mn-cs"/>
+              </a:rPr>
+              <a:t/>
+            </a:r>
+            <a:r>
+              <a:rPr lang="en-US" altLang="ko-KR" sz="1200" b="0" i="0" kern="1200" dirty="0">
+                <a:solidFill>
+                  <a:schemeClr val="tx1"/>
+                </a:solidFill>
+                <a:effectLst/>
+                <a:latin typeface="+mn-lt"/>
+                <a:ea typeface="+mn-ea"/>
+                <a:cs typeface="+mn-cs"/>
+              </a:rPr>
+              <a:t/>
+            </a:r>
+            <a:r>
+              <a:rPr lang="ko-KR" altLang="en-US" sz="1200" b="0" i="0" kern="1200" dirty="0">
+                <a:solidFill>
+                  <a:schemeClr val="tx1"/>
+                </a:solidFill>
+                <a:effectLst/>
+                <a:latin typeface="+mn-lt"/>
+                <a:ea typeface="+mn-ea"/>
+                <a:cs typeface="+mn-cs"/>
+              </a:rPr>
+              <a:t/>
+            </a:r>
+            <a:r>
+              <a:rPr lang="en-US" altLang="ko-KR" sz="1200" b="0" i="0" kern="1200" dirty="0">
+                <a:solidFill>
+                  <a:schemeClr val="tx1"/>
+                </a:solidFill>
+                <a:effectLst/>
+                <a:latin typeface="+mn-lt"/>
+                <a:ea typeface="+mn-ea"/>
+                <a:cs typeface="+mn-cs"/>
+              </a:rPr>
+              <a:t/>
+            </a:r>
+            <a:r>
+              <a:rPr lang="ko-KR" altLang="en-US" sz="1200" b="0" i="0" kern="1200" dirty="0">
+                <a:solidFill>
+                  <a:schemeClr val="tx1"/>
+                </a:solidFill>
+                <a:effectLst/>
+                <a:latin typeface="+mn-lt"/>
+                <a:ea typeface="+mn-ea"/>
+                <a:cs typeface="+mn-cs"/>
+              </a:rPr>
+              <a:t/>
+            </a:r>
+            <a:r>
+              <a:rPr lang="en-US" altLang="ko-KR" sz="1200" b="0" i="0" kern="1200" dirty="0">
+                <a:solidFill>
+                  <a:schemeClr val="tx1"/>
+                </a:solidFill>
+                <a:effectLst/>
+                <a:latin typeface="+mn-lt"/>
+                <a:ea typeface="+mn-ea"/>
+                <a:cs typeface="+mn-cs"/>
+              </a:rPr>
+              <a:t/>
+            </a:r>
+            <a:endParaRPr lang="en-US" dirty="0"/>
           </a:p>
         </p:txBody>
       </p:sp>
@@ -382,13 +504,126 @@
           <a:lstStyle/>
           <a:p>
             <a:r>
-              <a:rPr lang="ko-KR" altLang="en-US" dirty="0"/>
-              <a:t/>
-            </a:r>
-            <a:r>
-              <a:rPr lang="en-US" dirty="0"/>
-              <a:t/>
-            </a:r>
+              <a:rPr lang="ko-KR" altLang="en-US" sz="1200" b="0" i="0" kern="1200" dirty="0">
+                <a:solidFill>
+                  <a:schemeClr val="tx1"/>
+                </a:solidFill>
+                <a:effectLst/>
+                <a:latin typeface="+mn-lt"/>
+                <a:ea typeface="+mn-ea"/>
+                <a:cs typeface="+mn-cs"/>
+              </a:rPr>
+              <a:t/>
+            </a:r>
+            <a:r>
+              <a:rPr lang="en-US" altLang="ko-KR" sz="1200" b="0" i="0" kern="1200" dirty="0">
+                <a:solidFill>
+                  <a:schemeClr val="tx1"/>
+                </a:solidFill>
+                <a:effectLst/>
+                <a:latin typeface="+mn-lt"/>
+                <a:ea typeface="+mn-ea"/>
+                <a:cs typeface="+mn-cs"/>
+              </a:rPr>
+              <a:t/>
+            </a:r>
+            <a:r>
+              <a:rPr lang="ko-KR" altLang="en-US" sz="1200" b="0" i="0" kern="1200" dirty="0">
+                <a:solidFill>
+                  <a:schemeClr val="tx1"/>
+                </a:solidFill>
+                <a:effectLst/>
+                <a:latin typeface="+mn-lt"/>
+                <a:ea typeface="+mn-ea"/>
+                <a:cs typeface="+mn-cs"/>
+              </a:rPr>
+              <a:t/>
+            </a:r>
+            <a:r>
+              <a:rPr lang="en-US" altLang="ko-KR" sz="1200" b="0" i="0" kern="1200" dirty="0">
+                <a:solidFill>
+                  <a:schemeClr val="tx1"/>
+                </a:solidFill>
+                <a:effectLst/>
+                <a:latin typeface="+mn-lt"/>
+                <a:ea typeface="+mn-ea"/>
+                <a:cs typeface="+mn-cs"/>
+              </a:rPr>
+              <a:t/>
+            </a:r>
+            <a:r>
+              <a:rPr lang="ko-KR" altLang="en-US" sz="1200" b="0" i="0" kern="1200" dirty="0">
+                <a:solidFill>
+                  <a:schemeClr val="tx1"/>
+                </a:solidFill>
+                <a:effectLst/>
+                <a:latin typeface="+mn-lt"/>
+                <a:ea typeface="+mn-ea"/>
+                <a:cs typeface="+mn-cs"/>
+              </a:rPr>
+              <a:t/>
+            </a:r>
+            <a:r>
+              <a:rPr lang="en-US" altLang="ko-KR" sz="1200" b="0" i="0" kern="1200" dirty="0">
+                <a:solidFill>
+                  <a:schemeClr val="tx1"/>
+                </a:solidFill>
+                <a:effectLst/>
+                <a:latin typeface="+mn-lt"/>
+                <a:ea typeface="+mn-ea"/>
+                <a:cs typeface="+mn-cs"/>
+              </a:rPr>
+              <a:t/>
+            </a:r>
+            <a:r>
+              <a:rPr lang="ko-KR" altLang="en-US" sz="1200" b="0" i="0" kern="1200" dirty="0">
+                <a:solidFill>
+                  <a:schemeClr val="tx1"/>
+                </a:solidFill>
+                <a:effectLst/>
+                <a:latin typeface="+mn-lt"/>
+                <a:ea typeface="+mn-ea"/>
+                <a:cs typeface="+mn-cs"/>
+              </a:rPr>
+              <a:t/>
+            </a:r>
+            <a:r>
+              <a:rPr lang="en-US" altLang="ko-KR" sz="1200" b="0" i="0" kern="1200" dirty="0">
+                <a:solidFill>
+                  <a:schemeClr val="tx1"/>
+                </a:solidFill>
+                <a:effectLst/>
+                <a:latin typeface="+mn-lt"/>
+                <a:ea typeface="+mn-ea"/>
+                <a:cs typeface="+mn-cs"/>
+              </a:rPr>
+              <a:t/>
+            </a:r>
+            <a:r>
+              <a:rPr lang="ko-KR" altLang="en-US" sz="1200" b="0" i="0" kern="1200" dirty="0">
+                <a:solidFill>
+                  <a:schemeClr val="tx1"/>
+                </a:solidFill>
+                <a:effectLst/>
+                <a:latin typeface="+mn-lt"/>
+                <a:ea typeface="+mn-ea"/>
+                <a:cs typeface="+mn-cs"/>
+              </a:rPr>
+              <a:t/>
+            </a:r>
+            <a:r>
+              <a:rPr lang="en-US" altLang="ko-KR" sz="1200" b="0" i="0" kern="1200" dirty="0">
+                <a:solidFill>
+                  <a:schemeClr val="tx1"/>
+                </a:solidFill>
+                <a:effectLst/>
+                <a:latin typeface="+mn-lt"/>
+                <a:ea typeface="+mn-ea"/>
+                <a:cs typeface="+mn-cs"/>
+              </a:rPr>
+              <a:t/>
+            </a:r>
+            <a:endParaRPr lang="en-US" dirty="0"/>
           </a:p>
         </p:txBody>
       </p:sp>
@@ -473,15 +708,75 @@
           <a:lstStyle/>
           <a:p>
             <a:r>
-              <a:rPr lang="en-US" dirty="0"/>
-              <a:t/>
-            </a:r>
-            <a:r>
-              <a:rPr lang="en-US" dirty="0" err="1"/>
-              <a:t/>
-            </a:r>
-            <a:r>
-              <a:rPr lang="en-US" dirty="0"/>
+              <a:rPr lang="ko-KR" altLang="en-US" dirty="0"/>
+              <a:t/>
+            </a:r>
+            <a:r>
+              <a:rPr lang="en-US" altLang="ko-KR" dirty="0"/>
+              <a:t/>
+            </a:r>
+            <a:r>
+              <a:rPr lang="ko-KR" altLang="en-US" dirty="0"/>
+              <a:t/>
+            </a:r>
+            <a:r>
+              <a:rPr lang="en-US" altLang="ko-KR" dirty="0"/>
+              <a:t/>
+            </a:r>
+            <a:r>
+              <a:rPr lang="ko-KR" altLang="en-US" dirty="0"/>
+              <a:t/>
+            </a:r>
+            <a:r>
+              <a:rPr lang="en-US" altLang="ko-KR" dirty="0"/>
+              <a:t/>
+            </a:r>
+            <a:r>
+              <a:rPr lang="ko-KR" altLang="en-US" dirty="0"/>
+              <a:t/>
+            </a:r>
+            <a:r>
+              <a:rPr lang="en-US" altLang="ko-KR" dirty="0"/>
+              <a:t/>
+            </a:r>
+            <a:r>
+              <a:rPr lang="ko-KR" altLang="en-US" dirty="0"/>
+              <a:t/>
+            </a:r>
+            <a:r>
+              <a:rPr lang="ko-KR" altLang="en-US" dirty="0" err="1"/>
+              <a:t/>
+            </a:r>
+            <a:r>
+              <a:rPr lang="ko-KR" altLang="en-US" dirty="0"/>
+              <a:t/>
+            </a:r>
+            <a:r>
+              <a:rPr lang="en-US" altLang="ko-KR" dirty="0"/>
+              <a:t/>
+            </a:r>
+            <a:r>
+              <a:rPr lang="ko-KR" altLang="en-US" dirty="0"/>
+              <a:t/>
+            </a:r>
+            <a:r>
+              <a:rPr lang="en-US" altLang="ko-KR" dirty="0"/>
+              <a:t/>
+            </a:r>
+            <a:r>
+              <a:rPr lang="ko-KR" altLang="en-US" dirty="0"/>
+              <a:t/>
+            </a:r>
+            <a:r>
+              <a:rPr lang="ko-KR" altLang="en-US" dirty="0" err="1"/>
+              <a:t/>
+            </a:r>
+            <a:r>
+              <a:rPr lang="ko-KR" altLang="en-US" dirty="0"/>
+              <a:t/>
+            </a:r>
+            <a:r>
+              <a:rPr lang="en-US" altLang="ko-KR" dirty="0"/>
               <a:t/>
             </a:r>
           </a:p>
@@ -568,7 +863,115 @@
           <a:lstStyle/>
           <a:p>
             <a:r>
+              <a:rPr lang="ko-KR" altLang="en-US" dirty="0"/>
+              <a:t/>
+            </a:r>
+            <a:r>
+              <a:rPr lang="ko-KR" altLang="en-US" dirty="0" err="1"/>
+              <a:t/>
+            </a:r>
+            <a:r>
+              <a:rPr lang="ko-KR" altLang="en-US" dirty="0"/>
+              <a:t/>
+            </a:r>
+            <a:r>
               <a:rPr lang="en-US" dirty="0"/>
+              <a:t/>
+            </a:r>
+            <a:r>
+              <a:rPr lang="ko-KR" altLang="en-US" dirty="0"/>
+              <a:t/>
+            </a:r>
+            <a:r>
+              <a:rPr lang="en-US" altLang="ko-KR" dirty="0"/>
+              <a:t/>
+            </a:r>
+            <a:r>
+              <a:rPr lang="ko-KR" altLang="en-US" dirty="0"/>
+              <a:t/>
+            </a:r>
+            <a:r>
+              <a:rPr lang="en-US" altLang="ko-KR" dirty="0"/>
+              <a:t/>
+            </a:r>
+            <a:r>
+              <a:rPr lang="ko-KR" altLang="en-US" dirty="0"/>
+              <a:t/>
+            </a:r>
+            <a:r>
+              <a:rPr lang="en-US" altLang="ko-KR" dirty="0"/>
+              <a:t/>
+            </a:r>
+            <a:r>
+              <a:rPr lang="ko-KR" altLang="en-US" dirty="0"/>
+              <a:t/>
+            </a:r>
+            <a:r>
+              <a:rPr lang="en-US" dirty="0"/>
+              <a:t/>
+            </a:r>
+            <a:r>
+              <a:rPr lang="ko-KR" altLang="en-US" dirty="0"/>
+              <a:t/>
+            </a:r>
+            <a:r>
+              <a:rPr lang="en-US" altLang="ko-KR" dirty="0"/>
+              <a:t/>
+            </a:r>
+            <a:r>
+              <a:rPr lang="ko-KR" altLang="en-US" dirty="0"/>
+              <a:t/>
+            </a:r>
+            <a:r>
+              <a:rPr lang="en-US" altLang="ko-KR" dirty="0"/>
+              <a:t/>
+            </a:r>
+            <a:r>
+              <a:rPr lang="ko-KR" altLang="en-US" dirty="0"/>
+              <a:t/>
+            </a:r>
+            <a:r>
+              <a:rPr lang="en-US" altLang="ko-KR" dirty="0"/>
+              <a:t/>
+            </a:r>
+            <a:r>
+              <a:rPr lang="ko-KR" altLang="en-US" dirty="0"/>
+              <a:t/>
+            </a:r>
+            <a:r>
+              <a:rPr lang="en-US" altLang="ko-KR" dirty="0"/>
+              <a:t/>
+            </a:r>
+            <a:r>
+              <a:rPr lang="ko-KR" altLang="en-US" dirty="0"/>
+              <a:t/>
+            </a:r>
+            <a:r>
+              <a:rPr lang="en-US" altLang="ko-KR" dirty="0"/>
+              <a:t/>
+            </a:r>
+            <a:r>
+              <a:rPr lang="ko-KR" altLang="en-US" dirty="0"/>
+              <a:t/>
+            </a:r>
+            <a:r>
+              <a:rPr lang="en-US" altLang="ko-KR" dirty="0"/>
+              <a:t/>
+            </a:r>
+            <a:r>
+              <a:rPr lang="ko-KR" altLang="en-US" dirty="0"/>
+              <a:t/>
+            </a:r>
+            <a:r>
+              <a:rPr lang="en-US" altLang="ko-KR" dirty="0"/>
+              <a:t/>
+            </a:r>
+            <a:r>
+              <a:rPr lang="ko-KR" altLang="en-US" dirty="0"/>
+              <a:t/>
+            </a:r>
+            <a:r>
+              <a:rPr lang="en-US" altLang="ko-KR" dirty="0"/>
               <a:t/>
             </a:r>
           </a:p>
@@ -655,7 +1058,115 @@
           <a:lstStyle/>
           <a:p>
             <a:r>
-              <a:rPr lang="en-US" dirty="0"/>
+              <a:rPr lang="ko-KR" altLang="en-US" dirty="0"/>
+              <a:t/>
+            </a:r>
+            <a:r>
+              <a:rPr lang="en-US" altLang="ko-KR" dirty="0"/>
+              <a:t/>
+            </a:r>
+            <a:r>
+              <a:rPr lang="ko-KR" altLang="en-US" dirty="0"/>
+              <a:t/>
+            </a:r>
+            <a:r>
+              <a:rPr lang="en-US" altLang="ko-KR" dirty="0"/>
+              <a:t/>
+            </a:r>
+            <a:r>
+              <a:rPr lang="ko-KR" altLang="en-US" dirty="0"/>
+              <a:t/>
+            </a:r>
+            <a:r>
+              <a:rPr lang="en-US" altLang="ko-KR" dirty="0"/>
+              <a:t/>
+            </a:r>
+            <a:r>
+              <a:rPr lang="ko-KR" altLang="en-US" dirty="0"/>
+              <a:t/>
+            </a:r>
+            <a:r>
+              <a:rPr lang="en-US" altLang="ko-KR" dirty="0"/>
+              <a:t/>
+            </a:r>
+            <a:r>
+              <a:rPr lang="ko-KR" altLang="en-US" dirty="0"/>
+              <a:t/>
+            </a:r>
+            <a:r>
+              <a:rPr lang="en-US" altLang="ko-KR" dirty="0"/>
+              <a:t/>
+            </a:r>
+            <a:r>
+              <a:rPr lang="ko-KR" altLang="en-US" dirty="0" err="1"/>
+              <a:t/>
+            </a:r>
+            <a:r>
+              <a:rPr lang="ko-KR" altLang="en-US" dirty="0"/>
+              <a:t/>
+            </a:r>
+            <a:r>
+              <a:rPr lang="en-US" altLang="ko-KR" dirty="0"/>
+              <a:t/>
+            </a:r>
+            <a:r>
+              <a:rPr lang="ko-KR" altLang="en-US" dirty="0" err="1"/>
+              <a:t/>
+            </a:r>
+            <a:r>
+              <a:rPr lang="ko-KR" altLang="en-US" dirty="0"/>
+              <a:t/>
+            </a:r>
+            <a:r>
+              <a:rPr lang="en-US" altLang="ko-KR" dirty="0"/>
+              <a:t/>
+            </a:r>
+            <a:r>
+              <a:rPr lang="ko-KR" altLang="en-US" dirty="0"/>
+              <a:t/>
+            </a:r>
+            <a:r>
+              <a:rPr lang="en-US" altLang="ko-KR" dirty="0"/>
+              <a:t/>
+            </a:r>
+            <a:r>
+              <a:rPr lang="ko-KR" altLang="en-US" dirty="0"/>
+              <a:t/>
+            </a:r>
+            <a:r>
+              <a:rPr lang="en-US" altLang="ko-KR" dirty="0"/>
+              <a:t/>
+            </a:r>
+            <a:r>
+              <a:rPr lang="ko-KR" altLang="en-US" dirty="0"/>
+              <a:t/>
+            </a:r>
+            <a:r>
+              <a:rPr lang="en-US" altLang="ko-KR" dirty="0"/>
+              <a:t/>
+            </a:r>
+            <a:r>
+              <a:rPr lang="ko-KR" altLang="en-US" dirty="0"/>
+              <a:t/>
+            </a:r>
+            <a:r>
+              <a:rPr lang="en-US" altLang="ko-KR" dirty="0"/>
+              <a:t/>
+            </a:r>
+            <a:r>
+              <a:rPr lang="ko-KR" altLang="en-US" dirty="0"/>
+              <a:t/>
+            </a:r>
+            <a:r>
+              <a:rPr lang="en-US" altLang="ko-KR" dirty="0"/>
+              <a:t/>
+            </a:r>
+            <a:r>
+              <a:rPr lang="ko-KR" altLang="en-US" dirty="0"/>
+              <a:t/>
+            </a:r>
+            <a:r>
+              <a:rPr lang="en-US" altLang="ko-KR" dirty="0"/>
               <a:t/>
             </a:r>
           </a:p>
@@ -742,9 +1253,102 @@
           <a:lstStyle/>
           <a:p>
             <a:r>
-              <a:rPr lang="en-US" dirty="0"/>
-              <a:t/>
-            </a:r>
+              <a:rPr lang="ko-KR" altLang="en-US" dirty="0"/>
+              <a:t/>
+            </a:r>
+            <a:r>
+              <a:rPr lang="en-US" altLang="ko-KR" dirty="0"/>
+              <a:t/>
+            </a:r>
+            <a:r>
+              <a:rPr lang="ko-KR" altLang="en-US" dirty="0"/>
+              <a:t/>
+            </a:r>
+            <a:r>
+              <a:rPr lang="en-US" altLang="ko-KR" dirty="0"/>
+              <a:t/>
+            </a:r>
+            <a:r>
+              <a:rPr lang="ko-KR" altLang="en-US" dirty="0"/>
+              <a:t/>
+            </a:r>
+            <a:r>
+              <a:rPr lang="en-US" altLang="ko-KR" dirty="0"/>
+              <a:t/>
+            </a:r>
+            <a:r>
+              <a:rPr lang="ko-KR" altLang="en-US" dirty="0"/>
+              <a:t/>
+            </a:r>
+            <a:r>
+              <a:rPr lang="en-US" altLang="ko-KR" dirty="0"/>
+              <a:t/>
+            </a:r>
+            <a:r>
+              <a:rPr lang="ko-KR" altLang="en-US" dirty="0"/>
+              <a:t/>
+            </a:r>
+            <a:r>
+              <a:rPr lang="ko-KR" altLang="en-US" dirty="0" err="1"/>
+              <a:t/>
+            </a:r>
+            <a:r>
+              <a:rPr lang="ko-KR" altLang="en-US" dirty="0"/>
+              <a:t/>
+            </a:r>
+            <a:r>
+              <a:rPr lang="en-US" altLang="ko-KR" dirty="0"/>
+              <a:t/>
+            </a:r>
+            <a:r>
+              <a:rPr lang="ko-KR" altLang="en-US" dirty="0"/>
+              <a:t/>
+            </a:r>
+            <a:r>
+              <a:rPr lang="en-US" altLang="ko-KR" dirty="0"/>
+              <a:t/>
+            </a:r>
+            <a:r>
+              <a:rPr lang="ko-KR" altLang="en-US" dirty="0"/>
+              <a:t/>
+            </a:r>
+            <a:r>
+              <a:rPr lang="ko-KR" altLang="en-US" dirty="0" err="1"/>
+              <a:t/>
+            </a:r>
+            <a:r>
+              <a:rPr lang="ko-KR" altLang="en-US" dirty="0"/>
+              <a:t/>
+            </a:r>
+            <a:r>
+              <a:rPr lang="en-US" altLang="ko-KR" dirty="0"/>
+              <a:t/>
+            </a:r>
+            <a:r>
+              <a:rPr lang="ko-KR" altLang="en-US" dirty="0"/>
+              <a:t/>
+            </a:r>
+            <a:r>
+              <a:rPr lang="en-US" altLang="ko-KR" dirty="0"/>
+              <a:t/>
+            </a:r>
+            <a:r>
+              <a:rPr lang="ko-KR" altLang="en-US" dirty="0"/>
+              <a:t/>
+            </a:r>
+            <a:r>
+              <a:rPr lang="en-US" altLang="ko-KR" dirty="0"/>
+              <a:t/>
+            </a:r>
+            <a:r>
+              <a:rPr lang="ko-KR" altLang="en-US" dirty="0"/>
+              <a:t/>
+            </a:r>
+            <a:r>
+              <a:rPr lang="en-US" altLang="ko-KR" dirty="0"/>
+              <a:t/>
+            </a:r>
+            <a:endParaRPr lang="en-US" dirty="0"/>
           </a:p>
         </p:txBody>
       </p:sp>
@@ -829,9 +1433,99 @@
           <a:lstStyle/>
           <a:p>
             <a:r>
-              <a:rPr lang="en-US" dirty="0"/>
-              <a:t/>
-            </a:r>
+              <a:rPr lang="ko-KR" altLang="en-US" dirty="0"/>
+              <a:t/>
+            </a:r>
+            <a:r>
+              <a:rPr lang="en-US" altLang="ko-KR" dirty="0"/>
+              <a:t/>
+            </a:r>
+          </a:p>
+          <a:p>
+            <a:r>
+              <a:rPr lang="ko-KR" altLang="en-US" dirty="0"/>
+              <a:t/>
+            </a:r>
+            <a:r>
+              <a:rPr lang="ko-KR" altLang="en-US" dirty="0" err="1"/>
+              <a:t/>
+            </a:r>
+            <a:r>
+              <a:rPr lang="en-US" altLang="ko-KR" dirty="0"/>
+              <a:t/>
+            </a:r>
+            <a:r>
+              <a:rPr lang="ko-KR" altLang="en-US" dirty="0" err="1"/>
+              <a:t/>
+            </a:r>
+            <a:r>
+              <a:rPr lang="ko-KR" altLang="en-US" dirty="0"/>
+              <a:t/>
+            </a:r>
+            <a:r>
+              <a:rPr lang="en-US" altLang="ko-KR" dirty="0"/>
+              <a:t/>
+            </a:r>
+            <a:r>
+              <a:rPr lang="ko-KR" altLang="en-US" dirty="0"/>
+              <a:t/>
+            </a:r>
+            <a:r>
+              <a:rPr lang="en-US" altLang="ko-KR" dirty="0"/>
+              <a:t/>
+            </a:r>
+            <a:r>
+              <a:rPr lang="ko-KR" altLang="en-US" dirty="0"/>
+              <a:t/>
+            </a:r>
+            <a:r>
+              <a:rPr lang="en-US" altLang="ko-KR" dirty="0"/>
+              <a:t/>
+            </a:r>
+            <a:r>
+              <a:rPr lang="ko-KR" altLang="en-US" dirty="0"/>
+              <a:t/>
+            </a:r>
+            <a:r>
+              <a:rPr lang="en-US" altLang="ko-KR" dirty="0"/>
+              <a:t/>
+            </a:r>
+          </a:p>
+          <a:p>
+            <a:r>
+              <a:rPr lang="ko-KR" altLang="en-US" dirty="0" err="1"/>
+              <a:t/>
+            </a:r>
+            <a:r>
+              <a:rPr lang="ko-KR" altLang="en-US" dirty="0"/>
+              <a:t/>
+            </a:r>
+            <a:r>
+              <a:rPr lang="en-US" altLang="ko-KR" dirty="0"/>
+              <a:t/>
+            </a:r>
+            <a:r>
+              <a:rPr lang="ko-KR" altLang="en-US" dirty="0"/>
+              <a:t/>
+            </a:r>
+            <a:r>
+              <a:rPr lang="en-US" altLang="ko-KR" dirty="0"/>
+              <a:t/>
+            </a:r>
+          </a:p>
+          <a:p>
+            <a:endParaRPr lang="en-US" altLang="ko-KR" dirty="0"/>
+          </a:p>
+          <a:p>
+            <a:r>
+              <a:rPr lang="ko-KR" altLang="en-US" dirty="0"/>
+              <a:t/>
+            </a:r>
+            <a:r>
+              <a:rPr lang="en-US" altLang="ko-KR"/>
+              <a:t/>
+            </a:r>
+            <a:endParaRPr lang="en-US" altLang="ko-KR" dirty="0"/>
           </a:p>
         </p:txBody>
       </p:sp>
@@ -3858,42 +4552,6 @@
           </a:p>
         </p:txBody>
       </p:sp>
-      <p:sp>
-        <p:nvSpPr>
-          <p:cNvPr id="26" name="text-57"/>
-          <p:cNvSpPr txBox="1"/>
-          <p:nvPr/>
-        </p:nvSpPr>
-        <p:spPr>
-          <a:xfrm>
-            <a:off x="457200" y="4434840"/>
-            <a:ext cx="8229600" cy="228600"/>
-          </a:xfrm>
-          <a:prstGeom prst="rect">
-            <a:avLst/>
-          </a:prstGeom>
-          <a:noFill/>
-          <a:ln/>
-        </p:spPr>
-        <p:txBody>
-          <a:bodyPr wrap="square" lIns="0" tIns="0" rIns="0" bIns="0" rtlCol="0" anchor="t"/>
-          <a:lstStyle/>
-          <a:p>
-            <a:pPr marL="0" indent="0" algn="ctr">
-              <a:buNone/>
-            </a:pPr>
-            <a:r>
-              <a:rPr lang="en-US" sz="1000" dirty="0">
-                <a:solidFill>
-                  <a:schemeClr val="accent3"/>
-                </a:solidFill>
-              </a:rPr>
-              <a:t>2021Q1 – 2026Q2  ·  22개 분기  ·  서울 425개 행정동  ·  100개 업종</a:t>
-            </a:r>
-            <a:endParaRPr lang="en-US" sz="1000" dirty="0"/>
-          </a:p>
-        </p:txBody>
-      </p:sp>
     </p:spTree>
   </p:cSld>
   <p:clrMapOvr>
@@ -5664,7 +6322,23 @@
                   <a:schemeClr val="tx2"/>
                 </a:solidFill>
               </a:rPr>
-              <a:t>   점포-행정동 · 원본 그대로 (양천구 신월7동 · 2025년 2분기)</a:t>
+              <a:t>   점포-행정동 · </a:t>
+            </a:r>
+            <a:r>
+              <a:rPr lang="en-US" sz="1100" dirty="0" err="1">
+                <a:solidFill>
+                  <a:schemeClr val="tx2"/>
+                </a:solidFill>
+              </a:rPr>
+              <a:t>원본</a:t>
+            </a:r>
+            <a:r>
+              <a:rPr lang="en-US" sz="1100" dirty="0">
+                <a:solidFill>
+                  <a:schemeClr val="tx2"/>
+                </a:solidFill>
+              </a:rPr>
+              <a:t> (양천구 신월7동 · 2025년 2분기)</a:t>
             </a:r>
             <a:endParaRPr lang="en-US" sz="1100" dirty="0"/>
           </a:p>
@@ -9248,42 +9922,6 @@
       </p:sp>
       <p:sp>
         <p:nvSpPr>
-          <p:cNvPr id="9" name="text-110"/>
-          <p:cNvSpPr txBox="1"/>
-          <p:nvPr/>
-        </p:nvSpPr>
-        <p:spPr>
-          <a:xfrm>
-            <a:off x="1234440" y="2276856"/>
-            <a:ext cx="2697480" cy="219456"/>
-          </a:xfrm>
-          <a:prstGeom prst="rect">
-            <a:avLst/>
-          </a:prstGeom>
-          <a:noFill/>
-          <a:ln/>
-        </p:spPr>
-        <p:txBody>
-          <a:bodyPr wrap="square" lIns="0" tIns="0" rIns="0" bIns="0" rtlCol="0" anchor="t"/>
-          <a:lstStyle/>
-          <a:p>
-            <a:pPr marL="0" indent="0">
-              <a:buNone/>
-            </a:pPr>
-            <a:r>
-              <a:rPr lang="en-US" sz="1000" dirty="0">
-                <a:solidFill>
-                  <a:schemeClr val="tx2"/>
-                </a:solidFill>
-              </a:rPr>
-              <a:t>세 데이터 결합 · 점포 5개 미만 제외 · 결측치 처리</a:t>
-            </a:r>
-            <a:endParaRPr lang="en-US" sz="1000" dirty="0"/>
-          </a:p>
-        </p:txBody>
-      </p:sp>
-      <p:sp>
-        <p:nvSpPr>
           <p:cNvPr id="10" name="text-111"/>
           <p:cNvSpPr txBox="1"/>
           <p:nvPr/>
@@ -9348,45 +9986,33 @@
                   <a:schemeClr val="tx1"/>
                 </a:solidFill>
               </a:rPr>
-              <a:t>결측치 처리 비교 실험</a:t>
+              <a:t>결측치 </a:t>
+            </a:r>
+            <a:r>
+              <a:rPr lang="en-US" sz="1300" b="1" dirty="0" err="1">
+                <a:solidFill>
+                  <a:schemeClr val="tx1"/>
+                </a:solidFill>
+              </a:rPr>
+              <a:t>처리</a:t>
+            </a:r>
+            <a:r>
+              <a:rPr lang="en-US" sz="1300" b="1" dirty="0">
+                <a:solidFill>
+                  <a:schemeClr val="tx1"/>
+                </a:solidFill>
+              </a:rPr>
+              <a:t> </a:t>
+            </a:r>
+            <a:r>
+              <a:rPr lang="en-US" sz="1300" b="1" dirty="0" err="1">
+                <a:solidFill>
+                  <a:schemeClr val="tx1"/>
+                </a:solidFill>
+              </a:rPr>
+              <a:t>비교</a:t>
             </a:r>
             <a:endParaRPr lang="en-US" sz="1300" dirty="0"/>
-          </a:p>
-        </p:txBody>
-      </p:sp>
-      <p:sp>
-        <p:nvSpPr>
-          <p:cNvPr id="12" name="text-113"/>
-          <p:cNvSpPr txBox="1"/>
-          <p:nvPr/>
-        </p:nvSpPr>
-        <p:spPr>
-          <a:xfrm>
-            <a:off x="1234440" y="2777490"/>
-            <a:ext cx="2697480" cy="219456"/>
-          </a:xfrm>
-          <a:prstGeom prst="rect">
-            <a:avLst/>
-          </a:prstGeom>
-          <a:noFill/>
-          <a:ln/>
-        </p:spPr>
-        <p:txBody>
-          <a:bodyPr wrap="square" lIns="0" tIns="0" rIns="0" bIns="0" rtlCol="0" anchor="t"/>
-          <a:lstStyle/>
-          <a:p>
-            <a:pPr marL="0" indent="0">
-              <a:buNone/>
-            </a:pPr>
-            <a:r>
-              <a:rPr lang="en-US" sz="1000" dirty="0">
-                <a:solidFill>
-                  <a:schemeClr val="tx2"/>
-                </a:solidFill>
-              </a:rPr>
-              <a:t>세 가지 방법을 같은 조건에서 비교 (오른쪽)</a:t>
-            </a:r>
-            <a:endParaRPr lang="en-US" sz="1000" dirty="0"/>
           </a:p>
         </p:txBody>
       </p:sp>
@@ -9464,42 +10090,6 @@
       </p:sp>
       <p:sp>
         <p:nvSpPr>
-          <p:cNvPr id="15" name="text-116"/>
-          <p:cNvSpPr txBox="1"/>
-          <p:nvPr/>
-        </p:nvSpPr>
-        <p:spPr>
-          <a:xfrm>
-            <a:off x="1234440" y="3278124"/>
-            <a:ext cx="2697480" cy="219456"/>
-          </a:xfrm>
-          <a:prstGeom prst="rect">
-            <a:avLst/>
-          </a:prstGeom>
-          <a:noFill/>
-          <a:ln/>
-        </p:spPr>
-        <p:txBody>
-          <a:bodyPr wrap="square" lIns="0" tIns="0" rIns="0" bIns="0" rtlCol="0" anchor="t"/>
-          <a:lstStyle/>
-          <a:p>
-            <a:pPr marL="0" indent="0">
-              <a:buNone/>
-            </a:pPr>
-            <a:r>
-              <a:rPr lang="en-US" sz="1000" dirty="0">
-                <a:solidFill>
-                  <a:schemeClr val="tx2"/>
-                </a:solidFill>
-              </a:rPr>
-              <a:t>결정 트리 · 랜덤 포레스트, GridSearchCV 튜닝</a:t>
-            </a:r>
-            <a:endParaRPr lang="en-US" sz="1000" dirty="0"/>
-          </a:p>
-        </p:txBody>
-      </p:sp>
-      <p:sp>
-        <p:nvSpPr>
           <p:cNvPr id="16" name="text-117"/>
           <p:cNvSpPr txBox="1"/>
           <p:nvPr/>
@@ -9572,42 +10162,6 @@
       </p:sp>
       <p:sp>
         <p:nvSpPr>
-          <p:cNvPr id="18" name="text-119"/>
-          <p:cNvSpPr txBox="1"/>
-          <p:nvPr/>
-        </p:nvSpPr>
-        <p:spPr>
-          <a:xfrm>
-            <a:off x="1234440" y="3778758"/>
-            <a:ext cx="2697480" cy="219456"/>
-          </a:xfrm>
-          <a:prstGeom prst="rect">
-            <a:avLst/>
-          </a:prstGeom>
-          <a:noFill/>
-          <a:ln/>
-        </p:spPr>
-        <p:txBody>
-          <a:bodyPr wrap="square" lIns="0" tIns="0" rIns="0" bIns="0" rtlCol="0" anchor="t"/>
-          <a:lstStyle/>
-          <a:p>
-            <a:pPr marL="0" indent="0">
-              <a:buNone/>
-            </a:pPr>
-            <a:r>
-              <a:rPr lang="en-US" sz="1000" dirty="0">
-                <a:solidFill>
-                  <a:schemeClr val="tx2"/>
-                </a:solidFill>
-              </a:rPr>
-              <a:t>지표별로 위험에 미친 영향 분석</a:t>
-            </a:r>
-            <a:endParaRPr lang="en-US" sz="1000" dirty="0"/>
-          </a:p>
-        </p:txBody>
-      </p:sp>
-      <p:sp>
-        <p:nvSpPr>
           <p:cNvPr id="19" name="text-120"/>
           <p:cNvSpPr txBox="1"/>
           <p:nvPr/>
@@ -9675,42 +10229,6 @@
               <a:t>웹 서비스 개발 · 배포</a:t>
             </a:r>
             <a:endParaRPr lang="en-US" sz="1300" dirty="0"/>
-          </a:p>
-        </p:txBody>
-      </p:sp>
-      <p:sp>
-        <p:nvSpPr>
-          <p:cNvPr id="21" name="text-122"/>
-          <p:cNvSpPr txBox="1"/>
-          <p:nvPr/>
-        </p:nvSpPr>
-        <p:spPr>
-          <a:xfrm>
-            <a:off x="1234440" y="4279392"/>
-            <a:ext cx="2697480" cy="219456"/>
-          </a:xfrm>
-          <a:prstGeom prst="rect">
-            <a:avLst/>
-          </a:prstGeom>
-          <a:noFill/>
-          <a:ln/>
-        </p:spPr>
-        <p:txBody>
-          <a:bodyPr wrap="square" lIns="0" tIns="0" rIns="0" bIns="0" rtlCol="0" anchor="t"/>
-          <a:lstStyle/>
-          <a:p>
-            <a:pPr marL="0" indent="0">
-              <a:buNone/>
-            </a:pPr>
-            <a:r>
-              <a:rPr lang="en-US" sz="1000" dirty="0">
-                <a:solidFill>
-                  <a:schemeClr val="tx2"/>
-                </a:solidFill>
-              </a:rPr>
-              <a:t>화면 · API 연동, 14주차 배포</a:t>
-            </a:r>
-            <a:endParaRPr lang="en-US" sz="1000" dirty="0"/>
           </a:p>
         </p:txBody>
       </p:sp>
@@ -9778,7 +10296,31 @@
                   <a:schemeClr val="tx1"/>
                 </a:solidFill>
               </a:rPr>
-              <a:t>결측치 처리 비교 실험</a:t>
+              <a:t>결측치 </a:t>
+            </a:r>
+            <a:r>
+              <a:rPr lang="en-US" sz="1400" b="1" dirty="0" err="1">
+                <a:solidFill>
+                  <a:schemeClr val="tx1"/>
+                </a:solidFill>
+              </a:rPr>
+              <a:t>처리</a:t>
+            </a:r>
+            <a:r>
+              <a:rPr lang="en-US" sz="1400" b="1" dirty="0">
+                <a:solidFill>
+                  <a:schemeClr val="tx1"/>
+                </a:solidFill>
+              </a:rPr>
+              <a:t> </a:t>
+            </a:r>
+            <a:r>
+              <a:rPr lang="en-US" sz="1400" b="1" dirty="0" err="1">
+                <a:solidFill>
+                  <a:schemeClr val="tx1"/>
+                </a:solidFill>
+              </a:rPr>
+              <a:t>비교</a:t>
             </a:r>
             <a:endParaRPr lang="en-US" sz="1400" dirty="0"/>
           </a:p>
@@ -9904,7 +10446,7 @@
         </p:nvSpPr>
         <p:spPr>
           <a:xfrm>
-            <a:off x="4910328" y="2560320"/>
+            <a:off x="4910328" y="2629725"/>
             <a:ext cx="3182112" cy="201168"/>
           </a:xfrm>
           <a:prstGeom prst="rect">
@@ -9921,58 +10463,38 @@
               <a:buNone/>
             </a:pPr>
             <a:r>
+              <a:rPr lang="en-US" sz="1200" b="1" dirty="0" err="1">
+                <a:solidFill>
+                  <a:schemeClr val="tx1"/>
+                </a:solidFill>
+              </a:rPr>
+              <a:t>중앙값</a:t>
+            </a:r>
+            <a:r>
               <a:rPr lang="en-US" sz="1200" b="1" dirty="0">
                 <a:solidFill>
                   <a:schemeClr val="tx1"/>
                 </a:solidFill>
               </a:rPr>
-              <a:t>중앙값 대체</a:t>
-            </a:r>
-            <a:r>
-              <a:rPr lang="en-US" sz="1000" b="1" dirty="0">
-                <a:solidFill>
-                  <a:schemeClr val="accent3"/>
-                </a:solidFill>
-              </a:rPr>
-              <a:t>   간단, 이상치에 강함</a:t>
+              <a:t> </a:t>
+            </a:r>
+            <a:r>
+              <a:rPr lang="en-US" sz="1200" b="1" dirty="0" err="1">
+                <a:solidFill>
+                  <a:schemeClr val="tx1"/>
+                </a:solidFill>
+              </a:rPr>
+              <a:t>대</a:t>
+            </a:r>
+            <a:r>
+              <a:rPr lang="ko-KR" altLang="en-US" sz="1200" b="1" dirty="0">
+                <a:solidFill>
+                  <a:schemeClr val="tx1"/>
+                </a:solidFill>
+              </a:rPr>
+              <a:t>체</a:t>
             </a:r>
             <a:endParaRPr lang="en-US" sz="1200" dirty="0"/>
-          </a:p>
-        </p:txBody>
-      </p:sp>
-      <p:sp>
-        <p:nvSpPr>
-          <p:cNvPr id="28" name="text-129"/>
-          <p:cNvSpPr txBox="1"/>
-          <p:nvPr/>
-        </p:nvSpPr>
-        <p:spPr>
-          <a:xfrm>
-            <a:off x="4910328" y="2770632"/>
-            <a:ext cx="3182112" cy="201168"/>
-          </a:xfrm>
-          <a:prstGeom prst="rect">
-            <a:avLst/>
-          </a:prstGeom>
-          <a:noFill/>
-          <a:ln/>
-        </p:spPr>
-        <p:txBody>
-          <a:bodyPr wrap="square" lIns="0" tIns="0" rIns="0" bIns="0" rtlCol="0" anchor="t"/>
-          <a:lstStyle/>
-          <a:p>
-            <a:pPr marL="0" indent="0">
-              <a:buNone/>
-            </a:pPr>
-            <a:r>
-              <a:rPr lang="en-US" sz="1000" dirty="0">
-                <a:solidFill>
-                  <a:schemeClr val="tx2"/>
-                </a:solidFill>
-              </a:rPr>
-              <a:t>같은 분기·업종 중앙값으로 채움 (현재 방식)</a:t>
-            </a:r>
-            <a:endParaRPr lang="en-US" sz="1000" dirty="0"/>
           </a:p>
         </p:txBody>
       </p:sp>
@@ -10052,7 +10574,7 @@
         </p:nvSpPr>
         <p:spPr>
           <a:xfrm>
-            <a:off x="4910328" y="2971800"/>
+            <a:off x="4910328" y="3041205"/>
             <a:ext cx="3182112" cy="201168"/>
           </a:xfrm>
           <a:prstGeom prst="rect">
@@ -10077,42 +10599,6 @@
               <a:t>표시값 + 결측 표시</a:t>
             </a:r>
             <a:endParaRPr lang="en-US" sz="1200" dirty="0"/>
-          </a:p>
-        </p:txBody>
-      </p:sp>
-      <p:sp>
-        <p:nvSpPr>
-          <p:cNvPr id="32" name="text-133"/>
-          <p:cNvSpPr txBox="1"/>
-          <p:nvPr/>
-        </p:nvSpPr>
-        <p:spPr>
-          <a:xfrm>
-            <a:off x="4910328" y="3182112"/>
-            <a:ext cx="3182112" cy="201168"/>
-          </a:xfrm>
-          <a:prstGeom prst="rect">
-            <a:avLst/>
-          </a:prstGeom>
-          <a:noFill/>
-          <a:ln/>
-        </p:spPr>
-        <p:txBody>
-          <a:bodyPr wrap="square" lIns="0" tIns="0" rIns="0" bIns="0" rtlCol="0" anchor="t"/>
-          <a:lstStyle/>
-          <a:p>
-            <a:pPr marL="0" indent="0">
-              <a:buNone/>
-            </a:pPr>
-            <a:r>
-              <a:rPr lang="en-US" sz="1000" dirty="0">
-                <a:solidFill>
-                  <a:schemeClr val="tx2"/>
-                </a:solidFill>
-              </a:rPr>
-              <a:t>-1로 채우고 '매출 제공 여부'·'신규 진입' 피처 추가</a:t>
-            </a:r>
-            <a:endParaRPr lang="en-US" sz="1000" dirty="0"/>
           </a:p>
         </p:txBody>
       </p:sp>
@@ -10192,7 +10678,7 @@
         </p:nvSpPr>
         <p:spPr>
           <a:xfrm>
-            <a:off x="4910328" y="3383280"/>
+            <a:off x="4910328" y="3452685"/>
             <a:ext cx="3182112" cy="201168"/>
           </a:xfrm>
           <a:prstGeom prst="rect">
@@ -10217,42 +10703,6 @@
               <a:t>결측 그대로 학습</a:t>
             </a:r>
             <a:endParaRPr lang="en-US" sz="1200" dirty="0"/>
-          </a:p>
-        </p:txBody>
-      </p:sp>
-      <p:sp>
-        <p:nvSpPr>
-          <p:cNvPr id="36" name="text-137"/>
-          <p:cNvSpPr txBox="1"/>
-          <p:nvPr/>
-        </p:nvSpPr>
-        <p:spPr>
-          <a:xfrm>
-            <a:off x="4910328" y="3593592"/>
-            <a:ext cx="3182112" cy="201168"/>
-          </a:xfrm>
-          <a:prstGeom prst="rect">
-            <a:avLst/>
-          </a:prstGeom>
-          <a:noFill/>
-          <a:ln/>
-        </p:spPr>
-        <p:txBody>
-          <a:bodyPr wrap="square" lIns="0" tIns="0" rIns="0" bIns="0" rtlCol="0" anchor="t"/>
-          <a:lstStyle/>
-          <a:p>
-            <a:pPr marL="0" indent="0">
-              <a:buNone/>
-            </a:pPr>
-            <a:r>
-              <a:rPr lang="en-US" sz="1000" dirty="0">
-                <a:solidFill>
-                  <a:schemeClr val="tx2"/>
-                </a:solidFill>
-              </a:rPr>
-              <a:t>scikit-learn 트리의 결측값 직접 처리 기능 사용</a:t>
-            </a:r>
-            <a:endParaRPr lang="en-US" sz="1000" dirty="0"/>
           </a:p>
         </p:txBody>
       </p:sp>
@@ -10283,50 +10733,6 @@
           <a:lstStyle/>
           <a:p>
             <a:endParaRPr lang="ko-KR" altLang="en-US"/>
-          </a:p>
-        </p:txBody>
-      </p:sp>
-      <p:sp>
-        <p:nvSpPr>
-          <p:cNvPr id="38" name="text-139"/>
-          <p:cNvSpPr txBox="1"/>
-          <p:nvPr/>
-        </p:nvSpPr>
-        <p:spPr>
-          <a:xfrm>
-            <a:off x="4480560" y="3904488"/>
-            <a:ext cx="3611880" cy="365760"/>
-          </a:xfrm>
-          <a:prstGeom prst="rect">
-            <a:avLst/>
-          </a:prstGeom>
-          <a:noFill/>
-          <a:ln/>
-        </p:spPr>
-        <p:txBody>
-          <a:bodyPr wrap="square" lIns="0" tIns="0" rIns="0" bIns="0" rtlCol="0" anchor="t"/>
-          <a:lstStyle/>
-          <a:p>
-            <a:pPr marL="0" indent="0">
-              <a:buNone/>
-            </a:pPr>
-            <a:r>
-              <a:rPr lang="en-US" sz="1000" b="1" dirty="0">
-                <a:solidFill>
-                  <a:schemeClr val="tx1"/>
-                </a:solidFill>
-              </a:rPr>
-              <a:t>평가  </a:t>
-            </a:r>
-            <a:r>
-              <a:rPr lang="en-US" sz="1000" dirty="0">
-                <a:solidFill>
-                  <a:schemeClr val="tx2"/>
-                </a:solidFill>
-              </a:rPr>
-              <a:t>같은 시간 기준 분할(학습 2021Q1–2025Q1 · 테스트 2025Q2–2026Q1)에서 Test AUC · Recall · F1을 비교해 가장 좋은 방법 채택</a:t>
-            </a:r>
-            <a:endParaRPr lang="en-US" sz="1000" dirty="0"/>
           </a:p>
         </p:txBody>
       </p:sp>

</xml_diff>